<commit_message>
Add Scandit pairing and starter pack
</commit_message>
<xml_diff>
--- a/slides/hercode-zenline-hackathon-intro.pptx
+++ b/slides/hercode-zenline-hackathon-intro.pptx
@@ -2,15 +2,15 @@
 <file path=ppt/presentation.xml><?xml version="1.0" encoding="utf-8"?>
 <p:presentation xmlns:p="http://schemas.openxmlformats.org/presentationml/2006/main">
   <p:sldMasterIdLst>
-    <p:sldMasterId xmlns:r="http://schemas.openxmlformats.org/officeDocument/2006/relationships" id="2147483648" r:id="R7c599d51f5804cbe"/>
+    <p:sldMasterId xmlns:r="http://schemas.openxmlformats.org/officeDocument/2006/relationships" id="2147483648" r:id="Rc4baf54ab80746bc"/>
   </p:sldMasterIdLst>
   <p:notesMasterIdLst>
-    <p:notesMasterId xmlns:r="http://schemas.openxmlformats.org/officeDocument/2006/relationships" r:id="R015d374da4f04a9d"/>
+    <p:notesMasterId xmlns:r="http://schemas.openxmlformats.org/officeDocument/2006/relationships" r:id="R14a4f2166e5a4e4f"/>
   </p:notesMasterIdLst>
   <p:sldIdLst>
-    <p:sldId xmlns:r="http://schemas.openxmlformats.org/officeDocument/2006/relationships" id="256" r:id="R57e6611d91864a99"/>
-    <p:sldId xmlns:r="http://schemas.openxmlformats.org/officeDocument/2006/relationships" id="257" r:id="R5b66a815a6924bc6"/>
-    <p:sldId xmlns:r="http://schemas.openxmlformats.org/officeDocument/2006/relationships" id="258" r:id="R74de8b9ce6f74bc1"/>
+    <p:sldId xmlns:r="http://schemas.openxmlformats.org/officeDocument/2006/relationships" id="256" r:id="R90d8a3222aff4fbe"/>
+    <p:sldId xmlns:r="http://schemas.openxmlformats.org/officeDocument/2006/relationships" id="257" r:id="R99554c2c548744bb"/>
+    <p:sldId xmlns:r="http://schemas.openxmlformats.org/officeDocument/2006/relationships" id="258" r:id="R14aeb089d0bd4214"/>
   </p:sldIdLst>
   <p:sldSz cx="12192000" cy="6858000"/>
   <p:notesSz cx="6858000" cy="9144000"/>
@@ -756,7 +756,7 @@
   </p:cSld>
   <p:clrMap bg1="lt1" tx1="dk1" bg2="lt2" tx2="dk2" accent1="accent1" accent2="accent2" accent3="accent3" accent4="accent4" accent5="accent5" accent6="accent6" hlink="hlink" folHlink="folHlink"/>
   <p:sldLayoutIdLst>
-    <p:sldLayoutId xmlns:r="http://schemas.openxmlformats.org/officeDocument/2006/relationships" id="2147483649" r:id="R550cd0675bf84f43"/>
+    <p:sldLayoutId xmlns:r="http://schemas.openxmlformats.org/officeDocument/2006/relationships" id="2147483649" r:id="R6d2cc7af1c604027"/>
   </p:sldLayoutIdLst>
   <p:txStyles>
     <p:titleStyle>
@@ -1320,7 +1320,7 @@
           <p:nvPr/>
         </p:nvPicPr>
         <p:blipFill>
-          <a:blip xmlns:r="http://schemas.openxmlformats.org/officeDocument/2006/relationships" xmlns:a="http://schemas.openxmlformats.org/drawingml/2006/main" r:embed="Rca622bab7b124aa9"/>
+          <a:blip xmlns:r="http://schemas.openxmlformats.org/officeDocument/2006/relationships" xmlns:a="http://schemas.openxmlformats.org/drawingml/2006/main" r:embed="R661ba91e1d2f48e6"/>
           <a:srcRect xmlns:a="http://schemas.openxmlformats.org/drawingml/2006/main" l="24049" t="0" r="24049" b="0"/>
           <a:stretch xmlns:a="http://schemas.openxmlformats.org/drawingml/2006/main">
             <a:fillRect l="0" t="0" r="0" b="0"/>
@@ -1341,7 +1341,7 @@
           <p:cNvPr id="2" name="">
             <a:extLst xmlns:a="http://schemas.openxmlformats.org/drawingml/2006/main">
               <a:ext uri="{FF2B5EF4-FFF2-40B4-BE49-F238E27FC236}">
-                <a16:creationId xmlns:a16="http://schemas.microsoft.com/office/drawing/2014/main" id="{FD2A90CF-4F86-42E5-8DF5-F947642D95F8}"/>
+                <a16:creationId xmlns:a16="http://schemas.microsoft.com/office/drawing/2014/main" id="{36095CD8-828A-40B2-9BD4-54E93A55FEFB}"/>
               </a:ext>
             </a:extLst>
           </p:cNvPr>
@@ -1374,7 +1374,7 @@
           <p:cNvPr id="3" name="">
             <a:extLst xmlns:a="http://schemas.openxmlformats.org/drawingml/2006/main">
               <a:ext uri="{FF2B5EF4-FFF2-40B4-BE49-F238E27FC236}">
-                <a16:creationId xmlns:a16="http://schemas.microsoft.com/office/drawing/2014/main" id="{0FD9BC37-97F0-438C-B861-097A1697C033}"/>
+                <a16:creationId xmlns:a16="http://schemas.microsoft.com/office/drawing/2014/main" id="{949A554E-10E8-4D16-AF05-E8A0CB63D3F0}"/>
               </a:ext>
             </a:extLst>
           </p:cNvPr>
@@ -1424,7 +1424,7 @@
           <p:cNvPr id="4" name="">
             <a:extLst xmlns:a="http://schemas.openxmlformats.org/drawingml/2006/main">
               <a:ext uri="{FF2B5EF4-FFF2-40B4-BE49-F238E27FC236}">
-                <a16:creationId xmlns:a16="http://schemas.microsoft.com/office/drawing/2014/main" id="{D548A362-23FF-42FC-AB76-BBCC9CE23E76}"/>
+                <a16:creationId xmlns:a16="http://schemas.microsoft.com/office/drawing/2014/main" id="{F00FB52E-3B66-4763-B3E4-40CCB7AC5993}"/>
               </a:ext>
             </a:extLst>
           </p:cNvPr>
@@ -1474,7 +1474,7 @@
           <p:cNvPr id="5" name="">
             <a:extLst xmlns:a="http://schemas.openxmlformats.org/drawingml/2006/main">
               <a:ext uri="{FF2B5EF4-FFF2-40B4-BE49-F238E27FC236}">
-                <a16:creationId xmlns:a16="http://schemas.microsoft.com/office/drawing/2014/main" id="{D88FC5C1-8362-4418-ADFB-057FCB4461B6}"/>
+                <a16:creationId xmlns:a16="http://schemas.microsoft.com/office/drawing/2014/main" id="{25EA532B-437B-495A-A4D1-6BBFFB407A84}"/>
               </a:ext>
             </a:extLst>
           </p:cNvPr>
@@ -1514,7 +1514,7 @@
                   <a:srgbClr val="DCE8DF"/>
                 </a:solidFill>
               </a:rPr>
-              <a:t>Spot the outdoor opportunity before it becomes obvious. Turn messy global signals into a recommendation a Swiss retailer could act on.</a:t>
+              <a:t>Zenline is the B2B side: turn messy global signals into a recommendation a Swiss retailer could act on.</a:t>
             </a:r>
           </a:p>
         </p:txBody>
@@ -1524,7 +1524,7 @@
           <p:cNvPr id="6" name="">
             <a:extLst xmlns:a="http://schemas.openxmlformats.org/drawingml/2006/main">
               <a:ext uri="{FF2B5EF4-FFF2-40B4-BE49-F238E27FC236}">
-                <a16:creationId xmlns:a16="http://schemas.microsoft.com/office/drawing/2014/main" id="{BEE326E2-5737-463F-80B2-7DF0EF1EC588}"/>
+                <a16:creationId xmlns:a16="http://schemas.microsoft.com/office/drawing/2014/main" id="{2216DF8D-CBF6-4520-A4E7-959D45434951}"/>
               </a:ext>
             </a:extLst>
           </p:cNvPr>
@@ -1578,7 +1578,7 @@
           <p:cNvPr id="7" name="">
             <a:extLst xmlns:a="http://schemas.openxmlformats.org/drawingml/2006/main">
               <a:ext uri="{FF2B5EF4-FFF2-40B4-BE49-F238E27FC236}">
-                <a16:creationId xmlns:a16="http://schemas.microsoft.com/office/drawing/2014/main" id="{408468A8-5D11-4A1C-BCFA-ABA7888564AF}"/>
+                <a16:creationId xmlns:a16="http://schemas.microsoft.com/office/drawing/2014/main" id="{C09A0630-84F2-47F4-97FA-2E974A926FDC}"/>
               </a:ext>
             </a:extLst>
           </p:cNvPr>
@@ -1632,7 +1632,7 @@
           <p:cNvPr id="8" name="">
             <a:extLst xmlns:a="http://schemas.openxmlformats.org/drawingml/2006/main">
               <a:ext uri="{FF2B5EF4-FFF2-40B4-BE49-F238E27FC236}">
-                <a16:creationId xmlns:a16="http://schemas.microsoft.com/office/drawing/2014/main" id="{FD9E2BA0-ADD0-48E1-8377-C8017834812A}"/>
+                <a16:creationId xmlns:a16="http://schemas.microsoft.com/office/drawing/2014/main" id="{26C86DB2-1618-42DD-B11C-AD7DF6A3C7D4}"/>
               </a:ext>
             </a:extLst>
           </p:cNvPr>
@@ -1686,7 +1686,7 @@
           <p:cNvPr id="9" name="">
             <a:extLst xmlns:a="http://schemas.openxmlformats.org/drawingml/2006/main">
               <a:ext uri="{FF2B5EF4-FFF2-40B4-BE49-F238E27FC236}">
-                <a16:creationId xmlns:a16="http://schemas.microsoft.com/office/drawing/2014/main" id="{1077D10E-2C74-4D11-93F0-43E9040915C2}"/>
+                <a16:creationId xmlns:a16="http://schemas.microsoft.com/office/drawing/2014/main" id="{4A73493A-F165-436B-8D1C-015E0F19E763}"/>
               </a:ext>
             </a:extLst>
           </p:cNvPr>
@@ -1734,7 +1734,7 @@
     </p:spTree>
     <p:extLst>
       <p:ext uri="{BB962C8B-B14F-4D97-AF65-F5344CB8AC3E}">
-        <p14:creationId xmlns:p14="http://schemas.microsoft.com/office/powerpoint/2010/main" val="1379795022"/>
+        <p14:creationId xmlns:p14="http://schemas.microsoft.com/office/powerpoint/2010/main" val="1140195724"/>
       </p:ext>
     </p:extLst>
   </p:cSld>
@@ -1765,7 +1765,7 @@
           <p:cNvPr id="1" name="">
             <a:extLst xmlns:a="http://schemas.openxmlformats.org/drawingml/2006/main">
               <a:ext uri="{FF2B5EF4-FFF2-40B4-BE49-F238E27FC236}">
-                <a16:creationId xmlns:a16="http://schemas.microsoft.com/office/drawing/2014/main" id="{934DDF12-E859-404B-9FC3-B853A1733B48}"/>
+                <a16:creationId xmlns:a16="http://schemas.microsoft.com/office/drawing/2014/main" id="{3B6A0885-1F2B-4DBB-A7E2-4EC008598D0B}"/>
               </a:ext>
             </a:extLst>
           </p:cNvPr>
@@ -1815,7 +1815,7 @@
           <p:cNvPr id="2" name="">
             <a:extLst xmlns:a="http://schemas.openxmlformats.org/drawingml/2006/main">
               <a:ext uri="{FF2B5EF4-FFF2-40B4-BE49-F238E27FC236}">
-                <a16:creationId xmlns:a16="http://schemas.microsoft.com/office/drawing/2014/main" id="{0A5C4E58-272F-41A5-B414-6A7E791ABE95}"/>
+                <a16:creationId xmlns:a16="http://schemas.microsoft.com/office/drawing/2014/main" id="{F19046A2-9D3B-48FE-A812-8495B84EB591}"/>
               </a:ext>
             </a:extLst>
           </p:cNvPr>
@@ -1827,7 +1827,7 @@
         <p:spPr>
           <a:xfrm xmlns:a="http://schemas.openxmlformats.org/drawingml/2006/main">
             <a:off x="571500" y="971550"/>
-            <a:ext cx="6762750" cy="323850"/>
+            <a:ext cx="5905500" cy="323850"/>
           </a:xfrm>
           <a:prstGeom xmlns:a="http://schemas.openxmlformats.org/drawingml/2006/main" prst="rect">
             <a:avLst/>
@@ -1855,7 +1855,7 @@
                   <a:srgbClr val="46544D"/>
                 </a:solidFill>
               </a:rPr>
-              <a:t>Build a reusable opportunity-detection flow for a Swiss outdoor retailer.</a:t>
+              <a:t>Zenline: what to stock. Scandit: how shoppers find it.</a:t>
             </a:r>
           </a:p>
         </p:txBody>
@@ -1869,7 +1869,7 @@
           <p:nvPr/>
         </p:nvPicPr>
         <p:blipFill>
-          <a:blip xmlns:r="http://schemas.openxmlformats.org/officeDocument/2006/relationships" xmlns:a="http://schemas.openxmlformats.org/drawingml/2006/main" r:embed="Refdfb12aa5d747b3"/>
+          <a:blip xmlns:r="http://schemas.openxmlformats.org/officeDocument/2006/relationships" xmlns:a="http://schemas.openxmlformats.org/drawingml/2006/main" r:embed="Rb52efca336ec4d35"/>
           <a:srcRect xmlns:a="http://schemas.openxmlformats.org/drawingml/2006/main" l="6323" t="0" r="6323" b="0"/>
           <a:stretch xmlns:a="http://schemas.openxmlformats.org/drawingml/2006/main">
             <a:fillRect l="0" t="0" r="0" b="0"/>
@@ -1892,7 +1892,7 @@
           <p:cNvPr id="4" name="">
             <a:extLst xmlns:a="http://schemas.openxmlformats.org/drawingml/2006/main">
               <a:ext uri="{FF2B5EF4-FFF2-40B4-BE49-F238E27FC236}">
-                <a16:creationId xmlns:a16="http://schemas.microsoft.com/office/drawing/2014/main" id="{206788D3-E86B-496C-AF0F-BDE8895A037C}"/>
+                <a16:creationId xmlns:a16="http://schemas.microsoft.com/office/drawing/2014/main" id="{6D11200A-C027-4D23-8635-276FF916F2C1}"/>
               </a:ext>
             </a:extLst>
           </p:cNvPr>
@@ -1933,7 +1933,7 @@
           <p:cNvPr id="5" name="">
             <a:extLst xmlns:a="http://schemas.openxmlformats.org/drawingml/2006/main">
               <a:ext uri="{FF2B5EF4-FFF2-40B4-BE49-F238E27FC236}">
-                <a16:creationId xmlns:a16="http://schemas.microsoft.com/office/drawing/2014/main" id="{1770E581-C818-4CC7-9835-F635E1A26805}"/>
+                <a16:creationId xmlns:a16="http://schemas.microsoft.com/office/drawing/2014/main" id="{2B2D58DE-184B-494C-82C0-81B0791B6A8A}"/>
               </a:ext>
             </a:extLst>
           </p:cNvPr>
@@ -1985,7 +1985,7 @@
           <p:cNvPr id="6" name="">
             <a:extLst xmlns:a="http://schemas.openxmlformats.org/drawingml/2006/main">
               <a:ext uri="{FF2B5EF4-FFF2-40B4-BE49-F238E27FC236}">
-                <a16:creationId xmlns:a16="http://schemas.microsoft.com/office/drawing/2014/main" id="{6B1F9D2F-F913-4E69-9DAE-A1D2EE5F3DC3}"/>
+                <a16:creationId xmlns:a16="http://schemas.microsoft.com/office/drawing/2014/main" id="{230917F8-97A8-442D-B1C7-0CF69EFAE230}"/>
               </a:ext>
             </a:extLst>
           </p:cNvPr>
@@ -2035,7 +2035,7 @@
           <p:cNvPr id="7" name="">
             <a:extLst xmlns:a="http://schemas.openxmlformats.org/drawingml/2006/main">
               <a:ext uri="{FF2B5EF4-FFF2-40B4-BE49-F238E27FC236}">
-                <a16:creationId xmlns:a16="http://schemas.microsoft.com/office/drawing/2014/main" id="{EA86047A-456F-4E5C-B330-185B5207091A}"/>
+                <a16:creationId xmlns:a16="http://schemas.microsoft.com/office/drawing/2014/main" id="{0FEA169F-9857-4E0A-B8FB-D124FED73C01}"/>
               </a:ext>
             </a:extLst>
           </p:cNvPr>
@@ -2085,7 +2085,7 @@
           <p:cNvPr id="8" name="">
             <a:extLst xmlns:a="http://schemas.openxmlformats.org/drawingml/2006/main">
               <a:ext uri="{FF2B5EF4-FFF2-40B4-BE49-F238E27FC236}">
-                <a16:creationId xmlns:a16="http://schemas.microsoft.com/office/drawing/2014/main" id="{6E70CB26-B226-4E39-8E41-51BC1EBB0D07}"/>
+                <a16:creationId xmlns:a16="http://schemas.microsoft.com/office/drawing/2014/main" id="{451C7BFF-306B-4935-AE7C-FFC5394CD5F1}"/>
               </a:ext>
             </a:extLst>
           </p:cNvPr>
@@ -2126,7 +2126,7 @@
           <p:cNvPr id="9" name="">
             <a:extLst xmlns:a="http://schemas.openxmlformats.org/drawingml/2006/main">
               <a:ext uri="{FF2B5EF4-FFF2-40B4-BE49-F238E27FC236}">
-                <a16:creationId xmlns:a16="http://schemas.microsoft.com/office/drawing/2014/main" id="{93E43B56-91A7-4341-A176-BB5766B80AB7}"/>
+                <a16:creationId xmlns:a16="http://schemas.microsoft.com/office/drawing/2014/main" id="{436BBA59-7CC0-414B-9E8F-DCD08722B128}"/>
               </a:ext>
             </a:extLst>
           </p:cNvPr>
@@ -2178,7 +2178,7 @@
           <p:cNvPr id="10" name="">
             <a:extLst xmlns:a="http://schemas.openxmlformats.org/drawingml/2006/main">
               <a:ext uri="{FF2B5EF4-FFF2-40B4-BE49-F238E27FC236}">
-                <a16:creationId xmlns:a16="http://schemas.microsoft.com/office/drawing/2014/main" id="{960ABC5D-2A18-4DD3-BC95-BDCFFD461F0A}"/>
+                <a16:creationId xmlns:a16="http://schemas.microsoft.com/office/drawing/2014/main" id="{E5E70CC3-2BD9-4BCB-8C76-9B37501223AB}"/>
               </a:ext>
             </a:extLst>
           </p:cNvPr>
@@ -2228,7 +2228,7 @@
           <p:cNvPr id="11" name="">
             <a:extLst xmlns:a="http://schemas.openxmlformats.org/drawingml/2006/main">
               <a:ext uri="{FF2B5EF4-FFF2-40B4-BE49-F238E27FC236}">
-                <a16:creationId xmlns:a16="http://schemas.microsoft.com/office/drawing/2014/main" id="{F35B8240-2313-4A21-9197-DAC689198FF1}"/>
+                <a16:creationId xmlns:a16="http://schemas.microsoft.com/office/drawing/2014/main" id="{B25D6112-F0BA-4CBD-BADC-7C6B57A936C2}"/>
               </a:ext>
             </a:extLst>
           </p:cNvPr>
@@ -2278,7 +2278,7 @@
           <p:cNvPr id="12" name="">
             <a:extLst xmlns:a="http://schemas.openxmlformats.org/drawingml/2006/main">
               <a:ext uri="{FF2B5EF4-FFF2-40B4-BE49-F238E27FC236}">
-                <a16:creationId xmlns:a16="http://schemas.microsoft.com/office/drawing/2014/main" id="{82926BC9-8226-44A8-B28E-493BFD93ADEF}"/>
+                <a16:creationId xmlns:a16="http://schemas.microsoft.com/office/drawing/2014/main" id="{94A3C824-9EB4-4EA6-9AA6-8278212A93EB}"/>
               </a:ext>
             </a:extLst>
           </p:cNvPr>
@@ -2319,7 +2319,7 @@
           <p:cNvPr id="13" name="">
             <a:extLst xmlns:a="http://schemas.openxmlformats.org/drawingml/2006/main">
               <a:ext uri="{FF2B5EF4-FFF2-40B4-BE49-F238E27FC236}">
-                <a16:creationId xmlns:a16="http://schemas.microsoft.com/office/drawing/2014/main" id="{2B0EE580-6F90-4444-92B8-E37DD639E3C5}"/>
+                <a16:creationId xmlns:a16="http://schemas.microsoft.com/office/drawing/2014/main" id="{A4526203-6C79-4815-9980-01EC4AF4ACE8}"/>
               </a:ext>
             </a:extLst>
           </p:cNvPr>
@@ -2371,7 +2371,7 @@
           <p:cNvPr id="14" name="">
             <a:extLst xmlns:a="http://schemas.openxmlformats.org/drawingml/2006/main">
               <a:ext uri="{FF2B5EF4-FFF2-40B4-BE49-F238E27FC236}">
-                <a16:creationId xmlns:a16="http://schemas.microsoft.com/office/drawing/2014/main" id="{A453FBF0-BDB1-453D-8F70-65CDC733397E}"/>
+                <a16:creationId xmlns:a16="http://schemas.microsoft.com/office/drawing/2014/main" id="{C7543A04-BC5B-49D9-A712-B5591DFBEFBA}"/>
               </a:ext>
             </a:extLst>
           </p:cNvPr>
@@ -2421,7 +2421,7 @@
           <p:cNvPr id="15" name="">
             <a:extLst xmlns:a="http://schemas.openxmlformats.org/drawingml/2006/main">
               <a:ext uri="{FF2B5EF4-FFF2-40B4-BE49-F238E27FC236}">
-                <a16:creationId xmlns:a16="http://schemas.microsoft.com/office/drawing/2014/main" id="{6E60F46F-45A1-4DA3-B0DD-2DF718582546}"/>
+                <a16:creationId xmlns:a16="http://schemas.microsoft.com/office/drawing/2014/main" id="{5E2F9896-8B14-4D57-A09F-1874AEDF5860}"/>
               </a:ext>
             </a:extLst>
           </p:cNvPr>
@@ -2471,7 +2471,7 @@
           <p:cNvPr id="16" name="">
             <a:extLst xmlns:a="http://schemas.openxmlformats.org/drawingml/2006/main">
               <a:ext uri="{FF2B5EF4-FFF2-40B4-BE49-F238E27FC236}">
-                <a16:creationId xmlns:a16="http://schemas.microsoft.com/office/drawing/2014/main" id="{B7CD9DD8-C054-4C3E-BF5B-41D5B9540863}"/>
+                <a16:creationId xmlns:a16="http://schemas.microsoft.com/office/drawing/2014/main" id="{583D376F-EA7A-4810-BFEB-A57D8543850B}"/>
               </a:ext>
             </a:extLst>
           </p:cNvPr>
@@ -2512,7 +2512,7 @@
           <p:cNvPr id="17" name="">
             <a:extLst xmlns:a="http://schemas.openxmlformats.org/drawingml/2006/main">
               <a:ext uri="{FF2B5EF4-FFF2-40B4-BE49-F238E27FC236}">
-                <a16:creationId xmlns:a16="http://schemas.microsoft.com/office/drawing/2014/main" id="{AE1376C4-6401-461D-B50A-CF8314FBA577}"/>
+                <a16:creationId xmlns:a16="http://schemas.microsoft.com/office/drawing/2014/main" id="{8F6DACF5-8497-4135-8BBB-208A03A6495A}"/>
               </a:ext>
             </a:extLst>
           </p:cNvPr>
@@ -2564,7 +2564,7 @@
           <p:cNvPr id="18" name="">
             <a:extLst xmlns:a="http://schemas.openxmlformats.org/drawingml/2006/main">
               <a:ext uri="{FF2B5EF4-FFF2-40B4-BE49-F238E27FC236}">
-                <a16:creationId xmlns:a16="http://schemas.microsoft.com/office/drawing/2014/main" id="{A082F416-B6F8-46E9-BA28-BCB596E6299B}"/>
+                <a16:creationId xmlns:a16="http://schemas.microsoft.com/office/drawing/2014/main" id="{51220B6D-F267-4C4A-823B-2FAE9395953A}"/>
               </a:ext>
             </a:extLst>
           </p:cNvPr>
@@ -2614,7 +2614,7 @@
           <p:cNvPr id="19" name="">
             <a:extLst xmlns:a="http://schemas.openxmlformats.org/drawingml/2006/main">
               <a:ext uri="{FF2B5EF4-FFF2-40B4-BE49-F238E27FC236}">
-                <a16:creationId xmlns:a16="http://schemas.microsoft.com/office/drawing/2014/main" id="{F562860B-D912-4E35-A3A3-1030D904F3DD}"/>
+                <a16:creationId xmlns:a16="http://schemas.microsoft.com/office/drawing/2014/main" id="{436F39FE-01B6-4C0D-A6D5-E6F798ED5190}"/>
               </a:ext>
             </a:extLst>
           </p:cNvPr>
@@ -2664,7 +2664,7 @@
           <p:cNvPr id="20" name="">
             <a:extLst xmlns:a="http://schemas.openxmlformats.org/drawingml/2006/main">
               <a:ext uri="{FF2B5EF4-FFF2-40B4-BE49-F238E27FC236}">
-                <a16:creationId xmlns:a16="http://schemas.microsoft.com/office/drawing/2014/main" id="{16A55C47-BB8A-47A8-827D-D59DE8304064}"/>
+                <a16:creationId xmlns:a16="http://schemas.microsoft.com/office/drawing/2014/main" id="{1F6524D5-6C00-4C7D-914A-391234D9A9B2}"/>
               </a:ext>
             </a:extLst>
           </p:cNvPr>
@@ -2705,7 +2705,7 @@
           <p:cNvPr id="21" name="">
             <a:extLst xmlns:a="http://schemas.openxmlformats.org/drawingml/2006/main">
               <a:ext uri="{FF2B5EF4-FFF2-40B4-BE49-F238E27FC236}">
-                <a16:creationId xmlns:a16="http://schemas.microsoft.com/office/drawing/2014/main" id="{E8307DB9-337A-4B3C-B68B-46C6B8D46DC8}"/>
+                <a16:creationId xmlns:a16="http://schemas.microsoft.com/office/drawing/2014/main" id="{C67CB0B5-1C35-4493-BDCE-4F61381BD011}"/>
               </a:ext>
             </a:extLst>
           </p:cNvPr>
@@ -2717,7 +2717,7 @@
         <p:spPr>
           <a:xfrm xmlns:a="http://schemas.openxmlformats.org/drawingml/2006/main">
             <a:off x="7105650" y="4248150"/>
-            <a:ext cx="1619250" cy="285750"/>
+            <a:ext cx="1905000" cy="285750"/>
           </a:xfrm>
           <a:prstGeom xmlns:a="http://schemas.openxmlformats.org/drawingml/2006/main" prst="rect">
             <a:avLst/>
@@ -2745,7 +2745,7 @@
                   <a:srgbClr val="69B7D6"/>
                 </a:solidFill>
               </a:rPr>
-              <a:t>Starter case</a:t>
+              <a:t>Shared retail loop</a:t>
             </a:r>
           </a:p>
         </p:txBody>
@@ -2755,7 +2755,7 @@
           <p:cNvPr id="22" name="">
             <a:extLst xmlns:a="http://schemas.openxmlformats.org/drawingml/2006/main">
               <a:ext uri="{FF2B5EF4-FFF2-40B4-BE49-F238E27FC236}">
-                <a16:creationId xmlns:a16="http://schemas.microsoft.com/office/drawing/2014/main" id="{48E98125-3D21-4D87-A85F-7F46A1F5B308}"/>
+                <a16:creationId xmlns:a16="http://schemas.microsoft.com/office/drawing/2014/main" id="{3B825612-86D2-4D25-B15D-F915A85E610A}"/>
               </a:ext>
             </a:extLst>
           </p:cNvPr>
@@ -2795,7 +2795,7 @@
                   <a:srgbClr val="F7F4EC"/>
                 </a:solidFill>
               </a:rPr>
-              <a:t>Find outdoor opportunities for Switzerland/DACH: products, services, materials, occasions, assortment gaps, or community-led ideas.</a:t>
+              <a:t>Market signals -&gt; assortment decision -&gt; in-store shopper experience. Your task is the upstream B2B intelligence layer.</a:t>
             </a:r>
           </a:p>
         </p:txBody>
@@ -2805,7 +2805,7 @@
           <p:cNvPr id="23" name="">
             <a:extLst xmlns:a="http://schemas.openxmlformats.org/drawingml/2006/main">
               <a:ext uri="{FF2B5EF4-FFF2-40B4-BE49-F238E27FC236}">
-                <a16:creationId xmlns:a16="http://schemas.microsoft.com/office/drawing/2014/main" id="{848D597F-9812-4895-9FF9-BE454276201E}"/>
+                <a16:creationId xmlns:a16="http://schemas.microsoft.com/office/drawing/2014/main" id="{1943A9FC-8873-4369-B8F8-FC69805A18EE}"/>
               </a:ext>
             </a:extLst>
           </p:cNvPr>
@@ -2853,7 +2853,7 @@
     </p:spTree>
     <p:extLst>
       <p:ext uri="{BB962C8B-B14F-4D97-AF65-F5344CB8AC3E}">
-        <p14:creationId xmlns:p14="http://schemas.microsoft.com/office/powerpoint/2010/main" val="239448604"/>
+        <p14:creationId xmlns:p14="http://schemas.microsoft.com/office/powerpoint/2010/main" val="854043155"/>
       </p:ext>
     </p:extLst>
   </p:cSld>
@@ -2884,7 +2884,7 @@
           <p:cNvPr id="1" name="">
             <a:extLst xmlns:a="http://schemas.openxmlformats.org/drawingml/2006/main">
               <a:ext uri="{FF2B5EF4-FFF2-40B4-BE49-F238E27FC236}">
-                <a16:creationId xmlns:a16="http://schemas.microsoft.com/office/drawing/2014/main" id="{66515864-1F1B-4EFA-BD0D-B6C0DA50F779}"/>
+                <a16:creationId xmlns:a16="http://schemas.microsoft.com/office/drawing/2014/main" id="{D0FAE478-FD6A-411D-B8F2-77EDF67E512B}"/>
               </a:ext>
             </a:extLst>
           </p:cNvPr>
@@ -2934,7 +2934,7 @@
           <p:cNvPr id="2" name="">
             <a:extLst xmlns:a="http://schemas.openxmlformats.org/drawingml/2006/main">
               <a:ext uri="{FF2B5EF4-FFF2-40B4-BE49-F238E27FC236}">
-                <a16:creationId xmlns:a16="http://schemas.microsoft.com/office/drawing/2014/main" id="{7966A6BC-30C4-435C-A167-83565C5EBBD2}"/>
+                <a16:creationId xmlns:a16="http://schemas.microsoft.com/office/drawing/2014/main" id="{DB452F15-7B9F-4B0E-8373-8D9B643B2314}"/>
               </a:ext>
             </a:extLst>
           </p:cNvPr>
@@ -2984,7 +2984,7 @@
           <p:cNvPr id="3" name="">
             <a:extLst xmlns:a="http://schemas.openxmlformats.org/drawingml/2006/main">
               <a:ext uri="{FF2B5EF4-FFF2-40B4-BE49-F238E27FC236}">
-                <a16:creationId xmlns:a16="http://schemas.microsoft.com/office/drawing/2014/main" id="{83737649-F7FC-49DB-8C44-3FBF79B26BC0}"/>
+                <a16:creationId xmlns:a16="http://schemas.microsoft.com/office/drawing/2014/main" id="{91398574-9D09-4FEF-BC8C-FBCA0FE03B90}"/>
               </a:ext>
             </a:extLst>
           </p:cNvPr>
@@ -3025,7 +3025,7 @@
           <p:cNvPr id="4" name="">
             <a:extLst xmlns:a="http://schemas.openxmlformats.org/drawingml/2006/main">
               <a:ext uri="{FF2B5EF4-FFF2-40B4-BE49-F238E27FC236}">
-                <a16:creationId xmlns:a16="http://schemas.microsoft.com/office/drawing/2014/main" id="{C6FE175A-AED3-42E4-884C-C45FFA36CE86}"/>
+                <a16:creationId xmlns:a16="http://schemas.microsoft.com/office/drawing/2014/main" id="{C368D8C1-1447-4B55-AE7E-963F443F47C6}"/>
               </a:ext>
             </a:extLst>
           </p:cNvPr>
@@ -3075,7 +3075,7 @@
           <p:cNvPr id="5" name="">
             <a:extLst xmlns:a="http://schemas.openxmlformats.org/drawingml/2006/main">
               <a:ext uri="{FF2B5EF4-FFF2-40B4-BE49-F238E27FC236}">
-                <a16:creationId xmlns:a16="http://schemas.microsoft.com/office/drawing/2014/main" id="{CAF7617E-F10B-4626-ADBE-95DE1A878AA8}"/>
+                <a16:creationId xmlns:a16="http://schemas.microsoft.com/office/drawing/2014/main" id="{DCE9A7BD-2266-4713-86A0-47CA2F07F725}"/>
               </a:ext>
             </a:extLst>
           </p:cNvPr>
@@ -3125,7 +3125,7 @@
           <p:cNvPr id="6" name="">
             <a:extLst xmlns:a="http://schemas.openxmlformats.org/drawingml/2006/main">
               <a:ext uri="{FF2B5EF4-FFF2-40B4-BE49-F238E27FC236}">
-                <a16:creationId xmlns:a16="http://schemas.microsoft.com/office/drawing/2014/main" id="{6A05F0CD-C22E-411B-8C7A-A8C91DEB8182}"/>
+                <a16:creationId xmlns:a16="http://schemas.microsoft.com/office/drawing/2014/main" id="{7C89A88C-5220-4072-A52D-86FB21B699D3}"/>
               </a:ext>
             </a:extLst>
           </p:cNvPr>
@@ -3166,7 +3166,7 @@
           <p:cNvPr id="7" name="">
             <a:extLst xmlns:a="http://schemas.openxmlformats.org/drawingml/2006/main">
               <a:ext uri="{FF2B5EF4-FFF2-40B4-BE49-F238E27FC236}">
-                <a16:creationId xmlns:a16="http://schemas.microsoft.com/office/drawing/2014/main" id="{73332CFB-D4B9-49B6-987D-0A18F98A4164}"/>
+                <a16:creationId xmlns:a16="http://schemas.microsoft.com/office/drawing/2014/main" id="{5AC917BE-224A-4236-A2D8-2461D473210B}"/>
               </a:ext>
             </a:extLst>
           </p:cNvPr>
@@ -3216,7 +3216,7 @@
           <p:cNvPr id="8" name="">
             <a:extLst xmlns:a="http://schemas.openxmlformats.org/drawingml/2006/main">
               <a:ext uri="{FF2B5EF4-FFF2-40B4-BE49-F238E27FC236}">
-                <a16:creationId xmlns:a16="http://schemas.microsoft.com/office/drawing/2014/main" id="{A3D5FCDF-96DE-48AB-B273-ED26A3B01C62}"/>
+                <a16:creationId xmlns:a16="http://schemas.microsoft.com/office/drawing/2014/main" id="{C741323D-0320-419F-BA03-066B18081854}"/>
               </a:ext>
             </a:extLst>
           </p:cNvPr>
@@ -3266,7 +3266,7 @@
           <p:cNvPr id="9" name="">
             <a:extLst xmlns:a="http://schemas.openxmlformats.org/drawingml/2006/main">
               <a:ext uri="{FF2B5EF4-FFF2-40B4-BE49-F238E27FC236}">
-                <a16:creationId xmlns:a16="http://schemas.microsoft.com/office/drawing/2014/main" id="{FDA17AB2-7B11-45C3-8C8B-DA0D2EFB599E}"/>
+                <a16:creationId xmlns:a16="http://schemas.microsoft.com/office/drawing/2014/main" id="{7723C8E5-D79F-4E12-95F5-09C23D3151E6}"/>
               </a:ext>
             </a:extLst>
           </p:cNvPr>
@@ -3307,7 +3307,7 @@
           <p:cNvPr id="10" name="">
             <a:extLst xmlns:a="http://schemas.openxmlformats.org/drawingml/2006/main">
               <a:ext uri="{FF2B5EF4-FFF2-40B4-BE49-F238E27FC236}">
-                <a16:creationId xmlns:a16="http://schemas.microsoft.com/office/drawing/2014/main" id="{90DC8AF8-C0CC-4F72-9A07-FEF10098D1D9}"/>
+                <a16:creationId xmlns:a16="http://schemas.microsoft.com/office/drawing/2014/main" id="{DDFF090F-B67A-440B-994B-1758F472C57D}"/>
               </a:ext>
             </a:extLst>
           </p:cNvPr>
@@ -3357,7 +3357,7 @@
           <p:cNvPr id="11" name="">
             <a:extLst xmlns:a="http://schemas.openxmlformats.org/drawingml/2006/main">
               <a:ext uri="{FF2B5EF4-FFF2-40B4-BE49-F238E27FC236}">
-                <a16:creationId xmlns:a16="http://schemas.microsoft.com/office/drawing/2014/main" id="{4AB77739-9C63-4FF1-AB0F-69A9E0C655A2}"/>
+                <a16:creationId xmlns:a16="http://schemas.microsoft.com/office/drawing/2014/main" id="{55864587-414E-4ED8-A6DF-ECFE376ABA39}"/>
               </a:ext>
             </a:extLst>
           </p:cNvPr>
@@ -3407,7 +3407,7 @@
           <p:cNvPr id="12" name="">
             <a:extLst xmlns:a="http://schemas.openxmlformats.org/drawingml/2006/main">
               <a:ext uri="{FF2B5EF4-FFF2-40B4-BE49-F238E27FC236}">
-                <a16:creationId xmlns:a16="http://schemas.microsoft.com/office/drawing/2014/main" id="{B2B25D34-B580-4794-9E37-550FAF41425A}"/>
+                <a16:creationId xmlns:a16="http://schemas.microsoft.com/office/drawing/2014/main" id="{80B108E9-C36F-47F5-9D0B-C43C62CB45FD}"/>
               </a:ext>
             </a:extLst>
           </p:cNvPr>
@@ -3448,7 +3448,7 @@
           <p:cNvPr id="13" name="">
             <a:extLst xmlns:a="http://schemas.openxmlformats.org/drawingml/2006/main">
               <a:ext uri="{FF2B5EF4-FFF2-40B4-BE49-F238E27FC236}">
-                <a16:creationId xmlns:a16="http://schemas.microsoft.com/office/drawing/2014/main" id="{2DF7DF27-D087-40C7-AF3E-20D99549B426}"/>
+                <a16:creationId xmlns:a16="http://schemas.microsoft.com/office/drawing/2014/main" id="{2F57FD1C-7DE5-4B1F-B6B9-74EE3BEC5BF6}"/>
               </a:ext>
             </a:extLst>
           </p:cNvPr>
@@ -3498,7 +3498,7 @@
           <p:cNvPr id="14" name="">
             <a:extLst xmlns:a="http://schemas.openxmlformats.org/drawingml/2006/main">
               <a:ext uri="{FF2B5EF4-FFF2-40B4-BE49-F238E27FC236}">
-                <a16:creationId xmlns:a16="http://schemas.microsoft.com/office/drawing/2014/main" id="{673C6D03-DACC-492F-97B1-465CFE062B91}"/>
+                <a16:creationId xmlns:a16="http://schemas.microsoft.com/office/drawing/2014/main" id="{094C00E3-AEC2-4925-ABD3-2CA533CA69E4}"/>
               </a:ext>
             </a:extLst>
           </p:cNvPr>
@@ -3548,7 +3548,7 @@
           <p:cNvPr id="15" name="">
             <a:extLst xmlns:a="http://schemas.openxmlformats.org/drawingml/2006/main">
               <a:ext uri="{FF2B5EF4-FFF2-40B4-BE49-F238E27FC236}">
-                <a16:creationId xmlns:a16="http://schemas.microsoft.com/office/drawing/2014/main" id="{08E2A9C9-3CB3-4959-9379-11E55F3D3863}"/>
+                <a16:creationId xmlns:a16="http://schemas.microsoft.com/office/drawing/2014/main" id="{1A22BFAB-44E7-450D-A713-929C3F5815C6}"/>
               </a:ext>
             </a:extLst>
           </p:cNvPr>
@@ -3589,7 +3589,7 @@
           <p:cNvPr id="16" name="">
             <a:extLst xmlns:a="http://schemas.openxmlformats.org/drawingml/2006/main">
               <a:ext uri="{FF2B5EF4-FFF2-40B4-BE49-F238E27FC236}">
-                <a16:creationId xmlns:a16="http://schemas.microsoft.com/office/drawing/2014/main" id="{A1B39324-A085-45B6-B38E-3BFAFFD056C1}"/>
+                <a16:creationId xmlns:a16="http://schemas.microsoft.com/office/drawing/2014/main" id="{FB37511B-4DD2-4F00-9817-5B11A1F9F81A}"/>
               </a:ext>
             </a:extLst>
           </p:cNvPr>
@@ -3639,7 +3639,7 @@
           <p:cNvPr id="17" name="">
             <a:extLst xmlns:a="http://schemas.openxmlformats.org/drawingml/2006/main">
               <a:ext uri="{FF2B5EF4-FFF2-40B4-BE49-F238E27FC236}">
-                <a16:creationId xmlns:a16="http://schemas.microsoft.com/office/drawing/2014/main" id="{AD9B8E85-0299-41A2-86E5-44E086E3F421}"/>
+                <a16:creationId xmlns:a16="http://schemas.microsoft.com/office/drawing/2014/main" id="{A0348424-A8C9-4384-AA7D-5F941DB37C37}"/>
               </a:ext>
             </a:extLst>
           </p:cNvPr>
@@ -3693,7 +3693,7 @@
           <p:cNvPr id="18" name="">
             <a:extLst xmlns:a="http://schemas.openxmlformats.org/drawingml/2006/main">
               <a:ext uri="{FF2B5EF4-FFF2-40B4-BE49-F238E27FC236}">
-                <a16:creationId xmlns:a16="http://schemas.microsoft.com/office/drawing/2014/main" id="{A00744B5-1875-4C6E-B287-B4BC186E2D91}"/>
+                <a16:creationId xmlns:a16="http://schemas.microsoft.com/office/drawing/2014/main" id="{B633D9A5-A160-4CAF-A579-90BEE1AB2DD7}"/>
               </a:ext>
             </a:extLst>
           </p:cNvPr>
@@ -3747,7 +3747,7 @@
           <p:cNvPr id="19" name="">
             <a:extLst xmlns:a="http://schemas.openxmlformats.org/drawingml/2006/main">
               <a:ext uri="{FF2B5EF4-FFF2-40B4-BE49-F238E27FC236}">
-                <a16:creationId xmlns:a16="http://schemas.microsoft.com/office/drawing/2014/main" id="{E69909CE-9BED-443B-9035-D738974658CC}"/>
+                <a16:creationId xmlns:a16="http://schemas.microsoft.com/office/drawing/2014/main" id="{C8464EC8-4212-4355-B174-706049383527}"/>
               </a:ext>
             </a:extLst>
           </p:cNvPr>
@@ -3801,7 +3801,7 @@
           <p:cNvPr id="20" name="">
             <a:extLst xmlns:a="http://schemas.openxmlformats.org/drawingml/2006/main">
               <a:ext uri="{FF2B5EF4-FFF2-40B4-BE49-F238E27FC236}">
-                <a16:creationId xmlns:a16="http://schemas.microsoft.com/office/drawing/2014/main" id="{D00B89E4-EE7B-47B9-8918-CBD059F48413}"/>
+                <a16:creationId xmlns:a16="http://schemas.microsoft.com/office/drawing/2014/main" id="{E4A2EC3B-54E5-46C1-B3FE-339F71919798}"/>
               </a:ext>
             </a:extLst>
           </p:cNvPr>
@@ -3855,7 +3855,7 @@
           <p:cNvPr id="21" name="">
             <a:extLst xmlns:a="http://schemas.openxmlformats.org/drawingml/2006/main">
               <a:ext uri="{FF2B5EF4-FFF2-40B4-BE49-F238E27FC236}">
-                <a16:creationId xmlns:a16="http://schemas.microsoft.com/office/drawing/2014/main" id="{4E3EAC55-9FAD-4C3A-A2AE-D447933A1F4D}"/>
+                <a16:creationId xmlns:a16="http://schemas.microsoft.com/office/drawing/2014/main" id="{BC770F88-A823-4B9A-A7D5-0D4019FB6413}"/>
               </a:ext>
             </a:extLst>
           </p:cNvPr>
@@ -3909,7 +3909,7 @@
           <p:cNvPr id="22" name="">
             <a:extLst xmlns:a="http://schemas.openxmlformats.org/drawingml/2006/main">
               <a:ext uri="{FF2B5EF4-FFF2-40B4-BE49-F238E27FC236}">
-                <a16:creationId xmlns:a16="http://schemas.microsoft.com/office/drawing/2014/main" id="{29F3BE06-52A8-4DBA-AA91-4E6E13CCE639}"/>
+                <a16:creationId xmlns:a16="http://schemas.microsoft.com/office/drawing/2014/main" id="{97CF3D22-8767-4003-8D2D-070132765703}"/>
               </a:ext>
             </a:extLst>
           </p:cNvPr>
@@ -3940,7 +3940,7 @@
           <p:cNvPr id="23" name="">
             <a:extLst xmlns:a="http://schemas.openxmlformats.org/drawingml/2006/main">
               <a:ext uri="{FF2B5EF4-FFF2-40B4-BE49-F238E27FC236}">
-                <a16:creationId xmlns:a16="http://schemas.microsoft.com/office/drawing/2014/main" id="{E9C7BABC-D7E7-4B0D-96B3-C08D875C3841}"/>
+                <a16:creationId xmlns:a16="http://schemas.microsoft.com/office/drawing/2014/main" id="{861E0958-0723-41F5-B048-89D67C107584}"/>
               </a:ext>
             </a:extLst>
           </p:cNvPr>
@@ -3990,7 +3990,7 @@
           <p:cNvPr id="24" name="">
             <a:extLst xmlns:a="http://schemas.openxmlformats.org/drawingml/2006/main">
               <a:ext uri="{FF2B5EF4-FFF2-40B4-BE49-F238E27FC236}">
-                <a16:creationId xmlns:a16="http://schemas.microsoft.com/office/drawing/2014/main" id="{1D7538EB-6587-4EC8-B248-C94D5D2C88F0}"/>
+                <a16:creationId xmlns:a16="http://schemas.microsoft.com/office/drawing/2014/main" id="{F2AB05CF-C6B2-4B07-B19F-41FA99F13D57}"/>
               </a:ext>
             </a:extLst>
           </p:cNvPr>
@@ -4040,7 +4040,7 @@
           <p:cNvPr id="25" name="">
             <a:extLst xmlns:a="http://schemas.openxmlformats.org/drawingml/2006/main">
               <a:ext uri="{FF2B5EF4-FFF2-40B4-BE49-F238E27FC236}">
-                <a16:creationId xmlns:a16="http://schemas.microsoft.com/office/drawing/2014/main" id="{46A72D7B-1446-4171-BF5A-FA6CC07C5D99}"/>
+                <a16:creationId xmlns:a16="http://schemas.microsoft.com/office/drawing/2014/main" id="{ED11CB38-1065-4DD4-8895-99ECE809B6E1}"/>
               </a:ext>
             </a:extLst>
           </p:cNvPr>
@@ -4088,7 +4088,7 @@
     </p:spTree>
     <p:extLst>
       <p:ext uri="{BB962C8B-B14F-4D97-AF65-F5344CB8AC3E}">
-        <p14:creationId xmlns:p14="http://schemas.microsoft.com/office/powerpoint/2010/main" val="1144424240"/>
+        <p14:creationId xmlns:p14="http://schemas.microsoft.com/office/powerpoint/2010/main" val="551280035"/>
       </p:ext>
     </p:extLst>
   </p:cSld>

</xml_diff>